<commit_message>
remove debug mode and change consent form
</commit_message>
<xml_diff>
--- a/Task/Stimuli/Consent/Consent.pptx
+++ b/Task/Stimuli/Consent/Consent.pptx
@@ -197,7 +197,7 @@
           <a:p>
             <a:fld id="{2286492A-2CA2-E643-8AA6-7A3DBD9E2B39}" type="datetimeFigureOut">
               <a:rPr lang="en-US" smtClean="0"/>
-              <a:t>6/22/21</a:t>
+              <a:t>7/19/22</a:t>
             </a:fld>
             <a:endParaRPr lang="en-US"/>
           </a:p>
@@ -695,7 +695,7 @@
           <a:p>
             <a:fld id="{BA5230AD-8316-4848-86F6-EF97FAB217B6}" type="datetimeFigureOut">
               <a:rPr lang="en-US" smtClean="0"/>
-              <a:t>6/22/21</a:t>
+              <a:t>7/19/22</a:t>
             </a:fld>
             <a:endParaRPr lang="en-US"/>
           </a:p>
@@ -893,7 +893,7 @@
           <a:p>
             <a:fld id="{BA5230AD-8316-4848-86F6-EF97FAB217B6}" type="datetimeFigureOut">
               <a:rPr lang="en-US" smtClean="0"/>
-              <a:t>6/22/21</a:t>
+              <a:t>7/19/22</a:t>
             </a:fld>
             <a:endParaRPr lang="en-US"/>
           </a:p>
@@ -1101,7 +1101,7 @@
           <a:p>
             <a:fld id="{BA5230AD-8316-4848-86F6-EF97FAB217B6}" type="datetimeFigureOut">
               <a:rPr lang="en-US" smtClean="0"/>
-              <a:t>6/22/21</a:t>
+              <a:t>7/19/22</a:t>
             </a:fld>
             <a:endParaRPr lang="en-US"/>
           </a:p>
@@ -1299,7 +1299,7 @@
           <a:p>
             <a:fld id="{BA5230AD-8316-4848-86F6-EF97FAB217B6}" type="datetimeFigureOut">
               <a:rPr lang="en-US" smtClean="0"/>
-              <a:t>6/22/21</a:t>
+              <a:t>7/19/22</a:t>
             </a:fld>
             <a:endParaRPr lang="en-US"/>
           </a:p>
@@ -1574,7 +1574,7 @@
           <a:p>
             <a:fld id="{BA5230AD-8316-4848-86F6-EF97FAB217B6}" type="datetimeFigureOut">
               <a:rPr lang="en-US" smtClean="0"/>
-              <a:t>6/22/21</a:t>
+              <a:t>7/19/22</a:t>
             </a:fld>
             <a:endParaRPr lang="en-US"/>
           </a:p>
@@ -1839,7 +1839,7 @@
           <a:p>
             <a:fld id="{BA5230AD-8316-4848-86F6-EF97FAB217B6}" type="datetimeFigureOut">
               <a:rPr lang="en-US" smtClean="0"/>
-              <a:t>6/22/21</a:t>
+              <a:t>7/19/22</a:t>
             </a:fld>
             <a:endParaRPr lang="en-US"/>
           </a:p>
@@ -2251,7 +2251,7 @@
           <a:p>
             <a:fld id="{BA5230AD-8316-4848-86F6-EF97FAB217B6}" type="datetimeFigureOut">
               <a:rPr lang="en-US" smtClean="0"/>
-              <a:t>6/22/21</a:t>
+              <a:t>7/19/22</a:t>
             </a:fld>
             <a:endParaRPr lang="en-US"/>
           </a:p>
@@ -2392,7 +2392,7 @@
           <a:p>
             <a:fld id="{BA5230AD-8316-4848-86F6-EF97FAB217B6}" type="datetimeFigureOut">
               <a:rPr lang="en-US" smtClean="0"/>
-              <a:t>6/22/21</a:t>
+              <a:t>7/19/22</a:t>
             </a:fld>
             <a:endParaRPr lang="en-US"/>
           </a:p>
@@ -2505,7 +2505,7 @@
           <a:p>
             <a:fld id="{BA5230AD-8316-4848-86F6-EF97FAB217B6}" type="datetimeFigureOut">
               <a:rPr lang="en-US" smtClean="0"/>
-              <a:t>6/22/21</a:t>
+              <a:t>7/19/22</a:t>
             </a:fld>
             <a:endParaRPr lang="en-US"/>
           </a:p>
@@ -2816,7 +2816,7 @@
           <a:p>
             <a:fld id="{BA5230AD-8316-4848-86F6-EF97FAB217B6}" type="datetimeFigureOut">
               <a:rPr lang="en-US" smtClean="0"/>
-              <a:t>6/22/21</a:t>
+              <a:t>7/19/22</a:t>
             </a:fld>
             <a:endParaRPr lang="en-US"/>
           </a:p>
@@ -3104,7 +3104,7 @@
           <a:p>
             <a:fld id="{BA5230AD-8316-4848-86F6-EF97FAB217B6}" type="datetimeFigureOut">
               <a:rPr lang="en-US" smtClean="0"/>
-              <a:t>6/22/21</a:t>
+              <a:t>7/19/22</a:t>
             </a:fld>
             <a:endParaRPr lang="en-US"/>
           </a:p>
@@ -3345,7 +3345,7 @@
           <a:p>
             <a:fld id="{BA5230AD-8316-4848-86F6-EF97FAB217B6}" type="datetimeFigureOut">
               <a:rPr lang="en-US" smtClean="0"/>
-              <a:t>6/22/21</a:t>
+              <a:t>7/19/22</a:t>
             </a:fld>
             <a:endParaRPr lang="en-US"/>
           </a:p>
@@ -3842,6 +3842,36 @@
           </p:spPr>
         </p:pic>
       </p:grpSp>
+      <p:pic>
+        <p:nvPicPr>
+          <p:cNvPr id="2" name="Picture 1">
+            <a:extLst>
+              <a:ext uri="{FF2B5EF4-FFF2-40B4-BE49-F238E27FC236}">
+                <a16:creationId xmlns:a16="http://schemas.microsoft.com/office/drawing/2014/main" id="{DB15EBE5-F334-D2D2-509E-68A73E4A9043}"/>
+              </a:ext>
+            </a:extLst>
+          </p:cNvPr>
+          <p:cNvPicPr>
+            <a:picLocks noChangeAspect="1"/>
+          </p:cNvPicPr>
+          <p:nvPr/>
+        </p:nvPicPr>
+        <p:blipFill>
+          <a:blip r:embed="rId5"/>
+          <a:stretch>
+            <a:fillRect/>
+          </a:stretch>
+        </p:blipFill>
+        <p:spPr>
+          <a:xfrm>
+            <a:off x="7591879" y="6016133"/>
+            <a:ext cx="2663990" cy="489852"/>
+          </a:xfrm>
+          <a:prstGeom prst="rect">
+            <a:avLst/>
+          </a:prstGeom>
+        </p:spPr>
+      </p:pic>
     </p:spTree>
     <p:extLst>
       <p:ext uri="{BB962C8B-B14F-4D97-AF65-F5344CB8AC3E}">

</xml_diff>